<commit_message>
Repair deck markup and add motion and schema-check tools
pptxgenjs writes an <a:pPr> before every run in a multi-run paragraph,
which ECMA-376 forbids; 11 slides had it. interactions.py keeps one
pPr per paragraph and can add Morph/fade transitions and click builds.
check_xml.py validates every slide against pml.xsd, which the skill
validator does not do for slide timing.

Co-Authored-By: Claude Opus 5.5 <noreply@anthropic.com>
Claude-Session: https://claude.ai/code/session_01BywPiosptTHQ1sVbiaHEur
</commit_message>
<xml_diff>
--- a/presentation/kit-room-final-demo.pptx
+++ b/presentation/kit-room-final-demo.pptx
@@ -6478,9 +6478,6 @@
               </a:rPr>
               <a:t>INSERT </a:t>
             </a:r>
-            <a:pPr indent="0" marL="0">
-              <a:buNone/>
-            </a:pPr>
             <a:r>
               <a:rPr lang="en-US" sz="950" b="1" dirty="0">
                 <a:solidFill>
@@ -6595,9 +6592,6 @@
               </a:rPr>
               <a:t>INSERT </a:t>
             </a:r>
-            <a:pPr indent="0" marL="0">
-              <a:buNone/>
-            </a:pPr>
             <a:r>
               <a:rPr lang="en-US" sz="950" b="1" dirty="0">
                 <a:solidFill>
@@ -6712,9 +6706,6 @@
               </a:rPr>
               <a:t>INSERT </a:t>
             </a:r>
-            <a:pPr indent="0" marL="0">
-              <a:buNone/>
-            </a:pPr>
             <a:r>
               <a:rPr lang="en-US" sz="950" b="1" dirty="0">
                 <a:solidFill>
@@ -6829,9 +6820,6 @@
               </a:rPr>
               <a:t>INSERT </a:t>
             </a:r>
-            <a:pPr indent="0" marL="0">
-              <a:buNone/>
-            </a:pPr>
             <a:r>
               <a:rPr lang="en-US" sz="950" b="1" dirty="0">
                 <a:solidFill>
@@ -11274,12 +11262,6 @@
               </a:rPr>
               <a:t>The order and its event share one commit. </a:t>
             </a:r>
-            <a:pPr indent="0" marL="0">
-              <a:lnSpc>
-                <a:spcPct val="112000"/>
-              </a:lnSpc>
-              <a:buNone/>
-            </a:pPr>
             <a:r>
               <a:rPr lang="en-US" sz="1250" dirty="0">
                 <a:solidFill>
@@ -11791,12 +11773,6 @@
               </a:rPr>
               <a:t>EVIDENCE  </a:t>
             </a:r>
-            <a:pPr indent="0" marL="0">
-              <a:lnSpc>
-                <a:spcPct val="105000"/>
-              </a:lnSpc>
-              <a:buNone/>
-            </a:pPr>
             <a:r>
               <a:rPr lang="en-US" sz="1050" dirty="0">
                 <a:solidFill>
@@ -13046,12 +13022,6 @@
               </a:rPr>
               <a:t>EVIDENCE  </a:t>
             </a:r>
-            <a:pPr indent="0" marL="0">
-              <a:lnSpc>
-                <a:spcPct val="105000"/>
-              </a:lnSpc>
-              <a:buNone/>
-            </a:pPr>
             <a:r>
               <a:rPr lang="en-US" sz="1050" dirty="0">
                 <a:solidFill>
@@ -14595,12 +14565,6 @@
               </a:rPr>
               <a:t>EVIDENCE  </a:t>
             </a:r>
-            <a:pPr indent="0" marL="0">
-              <a:lnSpc>
-                <a:spcPct val="105000"/>
-              </a:lnSpc>
-              <a:buNone/>
-            </a:pPr>
             <a:r>
               <a:rPr lang="en-US" sz="1050" dirty="0">
                 <a:solidFill>
@@ -14910,9 +14874,6 @@
               </a:rPr>
               <a:t>AZ a  </a:t>
             </a:r>
-            <a:pPr indent="0" marL="0">
-              <a:buNone/>
-            </a:pPr>
             <a:r>
               <a:rPr lang="en-US" sz="950" dirty="0">
                 <a:solidFill>
@@ -15012,9 +14973,6 @@
               </a:rPr>
               <a:t>AZ b  </a:t>
             </a:r>
-            <a:pPr indent="0" marL="0">
-              <a:buNone/>
-            </a:pPr>
             <a:r>
               <a:rPr lang="en-US" sz="950" dirty="0">
                 <a:solidFill>
@@ -15114,9 +15072,6 @@
               </a:rPr>
               <a:t>AZ c  </a:t>
             </a:r>
-            <a:pPr indent="0" marL="0">
-              <a:buNone/>
-            </a:pPr>
             <a:r>
               <a:rPr lang="en-US" sz="950" dirty="0">
                 <a:solidFill>
@@ -15441,9 +15396,6 @@
               </a:rPr>
               <a:t>S3 GATEWAY ENDPOINT  </a:t>
             </a:r>
-            <a:pPr indent="0" marL="0">
-              <a:buNone/>
-            </a:pPr>
             <a:r>
               <a:rPr lang="en-US" sz="950" dirty="0">
                 <a:solidFill>
@@ -15883,12 +15835,6 @@
               </a:rPr>
               <a:t>EVIDENCE  </a:t>
             </a:r>
-            <a:pPr indent="0" marL="0">
-              <a:lnSpc>
-                <a:spcPct val="105000"/>
-              </a:lnSpc>
-              <a:buNone/>
-            </a:pPr>
             <a:r>
               <a:rPr lang="en-US" sz="1050" dirty="0">
                 <a:solidFill>
@@ -17396,12 +17342,6 @@
               </a:rPr>
               <a:t>EVIDENCE  </a:t>
             </a:r>
-            <a:pPr indent="0" marL="0">
-              <a:lnSpc>
-                <a:spcPct val="105000"/>
-              </a:lnSpc>
-              <a:buNone/>
-            </a:pPr>
             <a:r>
               <a:rPr lang="en-US" sz="1050" dirty="0">
                 <a:solidFill>
@@ -18160,9 +18100,6 @@
               </a:rPr>
               <a:t>Not claimed: </a:t>
             </a:r>
-            <a:pPr indent="0" marL="0">
-              <a:buNone/>
-            </a:pPr>
             <a:r>
               <a:rPr lang="en-US" sz="1250" dirty="0">
                 <a:solidFill>
@@ -24607,6 +24544,20 @@
               </a:rPr>
               <a:t>Connections. </a:t>
             </a:r>
+            <a:r>
+              <a:rPr lang="en-US" sz="1200" dirty="0">
+                <a:solidFill>
+                  <a:srgbClr val="B3A6DC"/>
+                </a:solidFill>
+                <a:latin typeface="Inter" pitchFamily="34" charset="0"/>
+                <a:ea typeface="Inter" pitchFamily="34" charset="-122"/>
+                <a:cs typeface="Inter" pitchFamily="34" charset="-120"/>
+              </a:rPr>
+              <a:t>115 allowed by the pools, 100 by Postgres. Each new pod adds up to 25.</a:t>
+            </a:r>
+            <a:endParaRPr lang="en-US" sz="1200" dirty="0"/>
+          </a:p>
+          <a:p>
             <a:pPr indent="0" marL="0">
               <a:lnSpc>
                 <a:spcPct val="110000"/>
@@ -24616,13 +24567,13 @@
             <a:r>
               <a:rPr lang="en-US" sz="1200" dirty="0">
                 <a:solidFill>
-                  <a:srgbClr val="B3A6DC"/>
+                  <a:srgbClr val="242E46"/>
                 </a:solidFill>
                 <a:latin typeface="Inter" pitchFamily="34" charset="0"/>
                 <a:ea typeface="Inter" pitchFamily="34" charset="-122"/>
                 <a:cs typeface="Inter" pitchFamily="34" charset="-120"/>
               </a:rPr>
-              <a:t>115 allowed by the pools, 100 by Postgres. Each new pod adds up to 25.</a:t>
+              <a:t> </a:t>
             </a:r>
             <a:endParaRPr lang="en-US" sz="1200" dirty="0"/>
           </a:p>
@@ -24634,15 +24585,26 @@
               <a:buNone/>
             </a:pPr>
             <a:r>
-              <a:rPr lang="en-US" sz="1200" dirty="0">
-                <a:solidFill>
-                  <a:srgbClr val="242E46"/>
+              <a:rPr lang="en-US" sz="1200" b="1" dirty="0">
+                <a:solidFill>
+                  <a:srgbClr val="F3F2F8"/>
                 </a:solidFill>
                 <a:latin typeface="Inter" pitchFamily="34" charset="0"/>
                 <a:ea typeface="Inter" pitchFamily="34" charset="-122"/>
                 <a:cs typeface="Inter" pitchFamily="34" charset="-120"/>
               </a:rPr>
-              <a:t> </a:t>
+              <a:t>Postgres itself. </a:t>
+            </a:r>
+            <a:r>
+              <a:rPr lang="en-US" sz="1200" dirty="0">
+                <a:solidFill>
+                  <a:srgbClr val="B3A6DC"/>
+                </a:solidFill>
+                <a:latin typeface="Inter" pitchFamily="34" charset="0"/>
+                <a:ea typeface="Inter" pitchFamily="34" charset="-122"/>
+                <a:cs typeface="Inter" pitchFamily="34" charset="-120"/>
+              </a:rPr>
+              <a:t>One writer on one volume.</a:t>
             </a:r>
             <a:endParaRPr lang="en-US" sz="1200" dirty="0"/>
           </a:p>
@@ -24654,16 +24616,19 @@
               <a:buNone/>
             </a:pPr>
             <a:r>
-              <a:rPr lang="en-US" sz="1200" b="1" dirty="0">
-                <a:solidFill>
-                  <a:srgbClr val="F3F2F8"/>
+              <a:rPr lang="en-US" sz="1200" dirty="0">
+                <a:solidFill>
+                  <a:srgbClr val="242E46"/>
                 </a:solidFill>
                 <a:latin typeface="Inter" pitchFamily="34" charset="0"/>
                 <a:ea typeface="Inter" pitchFamily="34" charset="-122"/>
                 <a:cs typeface="Inter" pitchFamily="34" charset="-120"/>
               </a:rPr>
-              <a:t>Postgres itself. </a:t>
-            </a:r>
+              <a:t> </a:t>
+            </a:r>
+            <a:endParaRPr lang="en-US" sz="1200" dirty="0"/>
+          </a:p>
+          <a:p>
             <a:pPr indent="0" marL="0">
               <a:lnSpc>
                 <a:spcPct val="110000"/>
@@ -24671,15 +24636,26 @@
               <a:buNone/>
             </a:pPr>
             <a:r>
-              <a:rPr lang="en-US" sz="1200" dirty="0">
-                <a:solidFill>
-                  <a:srgbClr val="B3A6DC"/>
+              <a:rPr lang="en-US" sz="1200" b="1" dirty="0">
+                <a:solidFill>
+                  <a:srgbClr val="F3F2F8"/>
                 </a:solidFill>
                 <a:latin typeface="Inter" pitchFamily="34" charset="0"/>
                 <a:ea typeface="Inter" pitchFamily="34" charset="-122"/>
                 <a:cs typeface="Inter" pitchFamily="34" charset="-120"/>
               </a:rPr>
-              <a:t>One writer on one volume.</a:t>
+              <a:t>Redis down. </a:t>
+            </a:r>
+            <a:r>
+              <a:rPr lang="en-US" sz="1200" dirty="0">
+                <a:solidFill>
+                  <a:srgbClr val="B3A6DC"/>
+                </a:solidFill>
+                <a:latin typeface="Inter" pitchFamily="34" charset="0"/>
+                <a:ea typeface="Inter" pitchFamily="34" charset="-122"/>
+                <a:cs typeface="Inter" pitchFamily="34" charset="-120"/>
+              </a:rPr>
+              <a:t>The gateway fails open: up, but unthrottled.</a:t>
             </a:r>
             <a:endParaRPr lang="en-US" sz="1200" dirty="0"/>
           </a:p>
@@ -24719,71 +24695,8 @@
                 <a:ea typeface="Inter" pitchFamily="34" charset="-122"/>
                 <a:cs typeface="Inter" pitchFamily="34" charset="-120"/>
               </a:rPr>
-              <a:t>Redis down. </a:t>
-            </a:r>
-            <a:pPr indent="0" marL="0">
-              <a:lnSpc>
-                <a:spcPct val="110000"/>
-              </a:lnSpc>
-              <a:buNone/>
-            </a:pPr>
-            <a:r>
-              <a:rPr lang="en-US" sz="1200" dirty="0">
-                <a:solidFill>
-                  <a:srgbClr val="B3A6DC"/>
-                </a:solidFill>
-                <a:latin typeface="Inter" pitchFamily="34" charset="0"/>
-                <a:ea typeface="Inter" pitchFamily="34" charset="-122"/>
-                <a:cs typeface="Inter" pitchFamily="34" charset="-120"/>
-              </a:rPr>
-              <a:t>The gateway fails open: up, but unthrottled.</a:t>
-            </a:r>
-            <a:endParaRPr lang="en-US" sz="1200" dirty="0"/>
-          </a:p>
-          <a:p>
-            <a:pPr indent="0" marL="0">
-              <a:lnSpc>
-                <a:spcPct val="110000"/>
-              </a:lnSpc>
-              <a:buNone/>
-            </a:pPr>
-            <a:r>
-              <a:rPr lang="en-US" sz="1200" dirty="0">
-                <a:solidFill>
-                  <a:srgbClr val="242E46"/>
-                </a:solidFill>
-                <a:latin typeface="Inter" pitchFamily="34" charset="0"/>
-                <a:ea typeface="Inter" pitchFamily="34" charset="-122"/>
-                <a:cs typeface="Inter" pitchFamily="34" charset="-120"/>
-              </a:rPr>
-              <a:t> </a:t>
-            </a:r>
-            <a:endParaRPr lang="en-US" sz="1200" dirty="0"/>
-          </a:p>
-          <a:p>
-            <a:pPr indent="0" marL="0">
-              <a:lnSpc>
-                <a:spcPct val="110000"/>
-              </a:lnSpc>
-              <a:buNone/>
-            </a:pPr>
-            <a:r>
-              <a:rPr lang="en-US" sz="1200" b="1" dirty="0">
-                <a:solidFill>
-                  <a:srgbClr val="F3F2F8"/>
-                </a:solidFill>
-                <a:latin typeface="Inter" pitchFamily="34" charset="0"/>
-                <a:ea typeface="Inter" pitchFamily="34" charset="-122"/>
-                <a:cs typeface="Inter" pitchFamily="34" charset="-120"/>
-              </a:rPr>
               <a:t>Worker behind. </a:t>
             </a:r>
-            <a:pPr indent="0" marL="0">
-              <a:lnSpc>
-                <a:spcPct val="110000"/>
-              </a:lnSpc>
-              <a:buNone/>
-            </a:pPr>
             <a:r>
               <a:rPr lang="en-US" sz="1200" dirty="0">
                 <a:solidFill>
@@ -27683,12 +27596,6 @@
               </a:rPr>
               <a:t>Status. </a:t>
             </a:r>
-            <a:pPr indent="0" marL="0">
-              <a:lnSpc>
-                <a:spcPct val="112000"/>
-              </a:lnSpc>
-              <a:buNone/>
-            </a:pPr>
             <a:r>
               <a:rPr lang="en-US" sz="1150" dirty="0">
                 <a:solidFill>
@@ -34987,9 +34894,6 @@
               </a:rPr>
               <a:t>LIVE  </a:t>
             </a:r>
-            <a:pPr indent="0" marL="0">
-              <a:buNone/>
-            </a:pPr>
             <a:r>
               <a:rPr lang="en-US" sz="1100" dirty="0">
                 <a:solidFill>
@@ -35001,9 +34905,6 @@
               </a:rPr>
               <a:t>dashboard.dev.eksv2.naimaosmann.com</a:t>
             </a:r>
-            <a:pPr indent="0" marL="0">
-              <a:buNone/>
-            </a:pPr>
             <a:r>
               <a:rPr lang="en-US" sz="1100" b="1" dirty="0">
                 <a:solidFill>
@@ -35015,9 +34916,6 @@
               </a:rPr>
               <a:t>      IF DEV IS DOWN  </a:t>
             </a:r>
-            <a:pPr indent="0" marL="0">
-              <a:buNone/>
-            </a:pPr>
             <a:r>
               <a:rPr lang="en-US" sz="1100" dirty="0">
                 <a:solidFill>
@@ -39091,9 +38989,6 @@
               </a:rPr>
               <a:t>PLATFORM   </a:t>
             </a:r>
-            <a:pPr indent="0" marL="0">
-              <a:buNone/>
-            </a:pPr>
             <a:r>
               <a:rPr lang="en-US" sz="950" dirty="0">
                 <a:solidFill>

</xml_diff>